<commit_message>
Add technical reference documents for OpenVLA and world model research
</commit_message>
<xml_diff>
--- a/vlaw_presentation.pptx
+++ b/vlaw_presentation.pptx
@@ -1753,7 +1753,7 @@
         <p:spPr>
           <a:xfrm>
             <a:off x="661429" y="3971343"/>
-            <a:ext cx="365485" cy="146194"/>
+            <a:ext cx="538609" cy="146194"/>
           </a:xfrm>
           <a:prstGeom prst="rect">
             <a:avLst/>
@@ -1778,9 +1778,8 @@
                 <a:latin typeface="Inter" pitchFamily="34" charset="0"/>
                 <a:ea typeface="Inter" pitchFamily="34" charset="-122"/>
                 <a:cs typeface="Inter" pitchFamily="34" charset="-120"/>
-                <a:hlinkClick r:id="rId5"/>
-              </a:rPr>
-              <a:t>马睿远</a:t>
+              </a:rPr>
+              <a:t>Austin-152</a:t>
             </a:r>
             <a:endParaRPr lang="en-US" sz="950" dirty="0"/>
           </a:p>

</xml_diff>